<commit_message>
Pokemon: seven exercises instead of nine
The two tracing exercises are one, the type chart and switching are gone.

Co-Authored-By: Claude Opus 5.5 <noreply@anthropic.com>
Claude-Session: https://claude.ai/code/session_012sjsUQBbC7zon57rWHoo9d
</commit_message>
<xml_diff>
--- a/slides/10 Pokemon.pptx
+++ b/slides/10 Pokemon.pptx
@@ -1932,7 +1932,7 @@
           <a:lstStyle/>
           <a:p>
             <a:r>
-              <a:t>Exercises: a glass cannon, types, save and load.</a:t>
+              <a:t>Exercises: a a glass cannon, save and load, and more on the site.</a:t>
             </a:r>
           </a:p>
           <a:p>
@@ -12313,23 +12313,6 @@
             </a:pPr>
             <a:r>
               <a:rPr lang="en"/>
-              <a:t>Types: Fire, Water, Grass, and super-effective hits</a:t>
-            </a:r>
-            <a:endParaRPr/>
-          </a:p>
-          <a:p>
-            <a:pPr indent="-330200" lvl="0" marL="457200" rtl="0" algn="l">
-              <a:spcBef>
-                <a:spcPts val="0"/>
-              </a:spcBef>
-              <a:spcAft>
-                <a:spcPts val="0"/>
-              </a:spcAft>
-              <a:buSzPts val="1600"/>
-              <a:buChar char="●"/>
-            </a:pPr>
-            <a:r>
-              <a:rPr lang="en"/>
               <a:t>Save and load the party, with a round-trip test</a:t>
             </a:r>
             <a:endParaRPr/>

</xml_diff>

<commit_message>
Pokemon: the new-species exercise says what it means, and types return as a stretch
Co-Authored-By: Claude Opus 5.5 <noreply@anthropic.com>
Claude-Session: https://claude.ai/code/session_012sjsUQBbC7zon57rWHoo9d
</commit_message>
<xml_diff>
--- a/slides/10 Pokemon.pptx
+++ b/slides/10 Pokemon.pptx
@@ -1932,7 +1932,7 @@
           <a:lstStyle/>
           <a:p>
             <a:r>
-              <a:t>Exercises: a a glass cannon, save and load, and more on the site.</a:t>
+              <a:t>Exercises: a a new species, save and load, and more on the site.</a:t>
             </a:r>
           </a:p>
           <a:p>
@@ -12296,7 +12296,7 @@
             </a:pPr>
             <a:r>
               <a:rPr lang="en"/>
-              <a:t>A glass cannon: a new species, only in the JSON</a:t>
+              <a:t>A new species that hits hard and breaks easily, only in the JSON</a:t>
             </a:r>
             <a:endParaRPr/>
           </a:p>

</xml_diff>